<commit_message>
Add GDPR and remaining security controls to the briefing.
Cover Turnstile, throttling, session revoke, field-level encryption,
headers, anomaly detection, identity-share passwords, call recordings,
data-subject rights, and Privacy Policy / Terms — without claiming
a GDPR certificate.

Co-authored-by: Cursor <cursoragent@cursor.com>
</commit_message>
<xml_diff>
--- a/docs/TM-ANTOINE-Service-Provider-Webinar.pptx
+++ b/docs/TM-ANTOINE-Service-Provider-Webinar.pptx
@@ -8385,7 +8385,7 @@
           </p:nvPr>
         </p:nvGraphicFramePr>
         <p:xfrm>
-          <a:off x="502920" y="1051560"/>
+          <a:off x="502920" y="914400"/>
           <a:ext cx="11155680" cy="914400"/>
         </p:xfrm>
         <a:graphic>
@@ -8393,8 +8393,8 @@
             <a:tbl>
               <a:tblPr/>
               <a:tblGrid>
-                <a:gridCol w="3200400"/>
-                <a:gridCol w="7955280"/>
+                <a:gridCol w="3017520"/>
+                <a:gridCol w="8138160"/>
               </a:tblGrid>
               <a:tr h="0">
                 <a:tc>
@@ -8758,7 +8758,7 @@
                           <a:ea typeface="Arial" pitchFamily="34" charset="-122"/>
                           <a:cs typeface="Arial" pitchFamily="34" charset="-120"/>
                         </a:rPr>
-                        <a:t>TLS in transit. Ciphertext at rest in the vault and R2.</a:t>
+                        <a:t>TLS in transit. Ciphertext at rest in the vault, R2, and call recordings. Passport numbers and dates of birth encrypted in the database.</a:t>
                       </a:r>
                       <a:endParaRPr lang="en-US" sz="1300" dirty="0">
                         <a:latin typeface="Arial" charset="0"/>
@@ -8828,7 +8828,7 @@
                           <a:ea typeface="Arial" pitchFamily="34" charset="-122"/>
                           <a:cs typeface="Arial" pitchFamily="34" charset="-120"/>
                         </a:rPr>
-                        <a:t>MFA</a:t>
+                        <a:t>MFA / door</a:t>
                       </a:r>
                       <a:endParaRPr lang="en-US" sz="1300" dirty="0">
                         <a:latin typeface="Arial" charset="0"/>
@@ -8896,7 +8896,559 @@
                           <a:ea typeface="Arial" pitchFamily="34" charset="-122"/>
                           <a:cs typeface="Arial" pitchFamily="34" charset="-120"/>
                         </a:rPr>
-                        <a:t>Email code on a new device now. Authenticator required after this webinar.</a:t>
+                        <a:t>Email code on a new device now. Authenticator required after this webinar. Turnstile + five-tries-per-minute throttle. Sessions and trusted devices can be revoked.</a:t>
+                      </a:r>
+                      <a:endParaRPr lang="en-US" sz="1300" dirty="0">
+                        <a:latin typeface="Arial" charset="0"/>
+                        <a:ea typeface="Arial" charset="0"/>
+                        <a:cs typeface="Arial" charset="0"/>
+                      </a:endParaRPr>
+                    </a:p>
+                  </a:txBody>
+                  <a:tcPr marL="101600" marR="101600" marT="76200" marB="76200" anchor="ctr">
+                    <a:lnL w="12700" cap="flat" cmpd="sng" algn="ctr">
+                      <a:solidFill>
+                        <a:srgbClr val="FFFFFF"/>
+                      </a:solidFill>
+                      <a:prstDash val="solid"/>
+                      <a:round/>
+                      <a:headEnd type="none" w="med" len="med"/>
+                      <a:tailEnd type="none" w="med" len="med"/>
+                    </a:lnL>
+                    <a:lnR w="12700" cap="flat" cmpd="sng" algn="ctr">
+                      <a:solidFill>
+                        <a:srgbClr val="FFFFFF"/>
+                      </a:solidFill>
+                      <a:prstDash val="solid"/>
+                      <a:round/>
+                      <a:headEnd type="none" w="med" len="med"/>
+                      <a:tailEnd type="none" w="med" len="med"/>
+                    </a:lnR>
+                    <a:lnT w="12700" cap="flat" cmpd="sng" algn="ctr">
+                      <a:solidFill>
+                        <a:srgbClr val="FFFFFF"/>
+                      </a:solidFill>
+                      <a:prstDash val="solid"/>
+                      <a:round/>
+                      <a:headEnd type="none" w="med" len="med"/>
+                      <a:tailEnd type="none" w="med" len="med"/>
+                    </a:lnT>
+                    <a:lnB w="6350" cap="flat" cmpd="sng" algn="ctr">
+                      <a:solidFill>
+                        <a:srgbClr val="000000"/>
+                      </a:solidFill>
+                      <a:prstDash val="solid"/>
+                      <a:round/>
+                      <a:headEnd type="none" w="med" len="med"/>
+                      <a:tailEnd type="none" w="med" len="med"/>
+                    </a:lnB>
+                    <a:solidFill>
+                      <a:srgbClr val="FFFFFF"/>
+                    </a:solidFill>
+                  </a:tcPr>
+                </a:tc>
+              </a:tr>
+              <a:tr h="0">
+                <a:tc>
+                  <a:txBody>
+                    <a:bodyPr/>
+                    <a:lstStyle/>
+                    <a:p>
+                      <a:pPr indent="0" marL="0">
+                        <a:buNone/>
+                      </a:pPr>
+                      <a:r>
+                        <a:rPr lang="en-US" sz="1300" b="1" dirty="0">
+                          <a:solidFill>
+                            <a:srgbClr val="000000"/>
+                          </a:solidFill>
+                          <a:latin typeface="Arial" pitchFamily="34" charset="0"/>
+                          <a:ea typeface="Arial" pitchFamily="34" charset="-122"/>
+                          <a:cs typeface="Arial" pitchFamily="34" charset="-120"/>
+                        </a:rPr>
+                        <a:t>Browser / edge</a:t>
+                      </a:r>
+                      <a:endParaRPr lang="en-US" sz="1300" dirty="0">
+                        <a:latin typeface="Arial" charset="0"/>
+                        <a:ea typeface="Arial" charset="0"/>
+                        <a:cs typeface="Arial" charset="0"/>
+                      </a:endParaRPr>
+                    </a:p>
+                  </a:txBody>
+                  <a:tcPr marL="101600" marR="101600" marT="76200" marB="76200" anchor="ctr">
+                    <a:lnL w="12700" cap="flat" cmpd="sng" algn="ctr">
+                      <a:solidFill>
+                        <a:srgbClr val="FFFFFF"/>
+                      </a:solidFill>
+                      <a:prstDash val="solid"/>
+                      <a:round/>
+                      <a:headEnd type="none" w="med" len="med"/>
+                      <a:tailEnd type="none" w="med" len="med"/>
+                    </a:lnL>
+                    <a:lnR w="12700" cap="flat" cmpd="sng" algn="ctr">
+                      <a:solidFill>
+                        <a:srgbClr val="FFFFFF"/>
+                      </a:solidFill>
+                      <a:prstDash val="solid"/>
+                      <a:round/>
+                      <a:headEnd type="none" w="med" len="med"/>
+                      <a:tailEnd type="none" w="med" len="med"/>
+                    </a:lnR>
+                    <a:lnT w="12700" cap="flat" cmpd="sng" algn="ctr">
+                      <a:solidFill>
+                        <a:srgbClr val="FFFFFF"/>
+                      </a:solidFill>
+                      <a:prstDash val="solid"/>
+                      <a:round/>
+                      <a:headEnd type="none" w="med" len="med"/>
+                      <a:tailEnd type="none" w="med" len="med"/>
+                    </a:lnT>
+                    <a:lnB w="6350" cap="flat" cmpd="sng" algn="ctr">
+                      <a:solidFill>
+                        <a:srgbClr val="000000"/>
+                      </a:solidFill>
+                      <a:prstDash val="solid"/>
+                      <a:round/>
+                      <a:headEnd type="none" w="med" len="med"/>
+                      <a:tailEnd type="none" w="med" len="med"/>
+                    </a:lnB>
+                    <a:solidFill>
+                      <a:srgbClr val="F2F2F2"/>
+                    </a:solidFill>
+                  </a:tcPr>
+                </a:tc>
+                <a:tc>
+                  <a:txBody>
+                    <a:bodyPr/>
+                    <a:lstStyle/>
+                    <a:p>
+                      <a:pPr indent="0" marL="0">
+                        <a:buNone/>
+                      </a:pPr>
+                      <a:r>
+                        <a:rPr lang="en-US" sz="1300" dirty="0">
+                          <a:solidFill>
+                            <a:srgbClr val="000000"/>
+                          </a:solidFill>
+                          <a:latin typeface="Arial" pitchFamily="34" charset="0"/>
+                          <a:ea typeface="Arial" pitchFamily="34" charset="-122"/>
+                          <a:cs typeface="Arial" pitchFamily="34" charset="-120"/>
+                        </a:rPr>
+                        <a:t>Cloudflare edge filter. CSP, HSTS, framing headers. Uploads never executed by the web server.</a:t>
+                      </a:r>
+                      <a:endParaRPr lang="en-US" sz="1300" dirty="0">
+                        <a:latin typeface="Arial" charset="0"/>
+                        <a:ea typeface="Arial" charset="0"/>
+                        <a:cs typeface="Arial" charset="0"/>
+                      </a:endParaRPr>
+                    </a:p>
+                  </a:txBody>
+                  <a:tcPr marL="101600" marR="101600" marT="76200" marB="76200" anchor="ctr">
+                    <a:lnL w="12700" cap="flat" cmpd="sng" algn="ctr">
+                      <a:solidFill>
+                        <a:srgbClr val="FFFFFF"/>
+                      </a:solidFill>
+                      <a:prstDash val="solid"/>
+                      <a:round/>
+                      <a:headEnd type="none" w="med" len="med"/>
+                      <a:tailEnd type="none" w="med" len="med"/>
+                    </a:lnL>
+                    <a:lnR w="12700" cap="flat" cmpd="sng" algn="ctr">
+                      <a:solidFill>
+                        <a:srgbClr val="FFFFFF"/>
+                      </a:solidFill>
+                      <a:prstDash val="solid"/>
+                      <a:round/>
+                      <a:headEnd type="none" w="med" len="med"/>
+                      <a:tailEnd type="none" w="med" len="med"/>
+                    </a:lnR>
+                    <a:lnT w="12700" cap="flat" cmpd="sng" algn="ctr">
+                      <a:solidFill>
+                        <a:srgbClr val="FFFFFF"/>
+                      </a:solidFill>
+                      <a:prstDash val="solid"/>
+                      <a:round/>
+                      <a:headEnd type="none" w="med" len="med"/>
+                      <a:tailEnd type="none" w="med" len="med"/>
+                    </a:lnT>
+                    <a:lnB w="6350" cap="flat" cmpd="sng" algn="ctr">
+                      <a:solidFill>
+                        <a:srgbClr val="000000"/>
+                      </a:solidFill>
+                      <a:prstDash val="solid"/>
+                      <a:round/>
+                      <a:headEnd type="none" w="med" len="med"/>
+                      <a:tailEnd type="none" w="med" len="med"/>
+                    </a:lnB>
+                    <a:solidFill>
+                      <a:srgbClr val="F2F2F2"/>
+                    </a:solidFill>
+                  </a:tcPr>
+                </a:tc>
+              </a:tr>
+              <a:tr h="0">
+                <a:tc>
+                  <a:txBody>
+                    <a:bodyPr/>
+                    <a:lstStyle/>
+                    <a:p>
+                      <a:pPr indent="0" marL="0">
+                        <a:buNone/>
+                      </a:pPr>
+                      <a:r>
+                        <a:rPr lang="en-US" sz="1300" b="1" dirty="0">
+                          <a:solidFill>
+                            <a:srgbClr val="000000"/>
+                          </a:solidFill>
+                          <a:latin typeface="Arial" pitchFamily="34" charset="0"/>
+                          <a:ea typeface="Arial" pitchFamily="34" charset="-122"/>
+                          <a:cs typeface="Arial" pitchFamily="34" charset="-120"/>
+                        </a:rPr>
+                        <a:t>Monitoring</a:t>
+                      </a:r>
+                      <a:endParaRPr lang="en-US" sz="1300" dirty="0">
+                        <a:latin typeface="Arial" charset="0"/>
+                        <a:ea typeface="Arial" charset="0"/>
+                        <a:cs typeface="Arial" charset="0"/>
+                      </a:endParaRPr>
+                    </a:p>
+                  </a:txBody>
+                  <a:tcPr marL="101600" marR="101600" marT="76200" marB="76200" anchor="ctr">
+                    <a:lnL w="12700" cap="flat" cmpd="sng" algn="ctr">
+                      <a:solidFill>
+                        <a:srgbClr val="FFFFFF"/>
+                      </a:solidFill>
+                      <a:prstDash val="solid"/>
+                      <a:round/>
+                      <a:headEnd type="none" w="med" len="med"/>
+                      <a:tailEnd type="none" w="med" len="med"/>
+                    </a:lnL>
+                    <a:lnR w="12700" cap="flat" cmpd="sng" algn="ctr">
+                      <a:solidFill>
+                        <a:srgbClr val="FFFFFF"/>
+                      </a:solidFill>
+                      <a:prstDash val="solid"/>
+                      <a:round/>
+                      <a:headEnd type="none" w="med" len="med"/>
+                      <a:tailEnd type="none" w="med" len="med"/>
+                    </a:lnR>
+                    <a:lnT w="12700" cap="flat" cmpd="sng" algn="ctr">
+                      <a:solidFill>
+                        <a:srgbClr val="FFFFFF"/>
+                      </a:solidFill>
+                      <a:prstDash val="solid"/>
+                      <a:round/>
+                      <a:headEnd type="none" w="med" len="med"/>
+                      <a:tailEnd type="none" w="med" len="med"/>
+                    </a:lnT>
+                    <a:lnB w="6350" cap="flat" cmpd="sng" algn="ctr">
+                      <a:solidFill>
+                        <a:srgbClr val="000000"/>
+                      </a:solidFill>
+                      <a:prstDash val="solid"/>
+                      <a:round/>
+                      <a:headEnd type="none" w="med" len="med"/>
+                      <a:tailEnd type="none" w="med" len="med"/>
+                    </a:lnB>
+                    <a:solidFill>
+                      <a:srgbClr val="FFFFFF"/>
+                    </a:solidFill>
+                  </a:tcPr>
+                </a:tc>
+                <a:tc>
+                  <a:txBody>
+                    <a:bodyPr/>
+                    <a:lstStyle/>
+                    <a:p>
+                      <a:pPr indent="0" marL="0">
+                        <a:buNone/>
+                      </a:pPr>
+                      <a:r>
+                        <a:rPr lang="en-US" sz="1300" dirty="0">
+                          <a:solidFill>
+                            <a:srgbClr val="000000"/>
+                          </a:solidFill>
+                          <a:latin typeface="Arial" pitchFamily="34" charset="0"/>
+                          <a:ea typeface="Arial" pitchFamily="34" charset="-122"/>
+                          <a:cs typeface="Arial" pitchFamily="34" charset="-120"/>
+                        </a:rPr>
+                        <a:t>Sign-in log. Detectors for impossible travel, address spikes, download bursts — human review, not auto-lock.</a:t>
+                      </a:r>
+                      <a:endParaRPr lang="en-US" sz="1300" dirty="0">
+                        <a:latin typeface="Arial" charset="0"/>
+                        <a:ea typeface="Arial" charset="0"/>
+                        <a:cs typeface="Arial" charset="0"/>
+                      </a:endParaRPr>
+                    </a:p>
+                  </a:txBody>
+                  <a:tcPr marL="101600" marR="101600" marT="76200" marB="76200" anchor="ctr">
+                    <a:lnL w="12700" cap="flat" cmpd="sng" algn="ctr">
+                      <a:solidFill>
+                        <a:srgbClr val="FFFFFF"/>
+                      </a:solidFill>
+                      <a:prstDash val="solid"/>
+                      <a:round/>
+                      <a:headEnd type="none" w="med" len="med"/>
+                      <a:tailEnd type="none" w="med" len="med"/>
+                    </a:lnL>
+                    <a:lnR w="12700" cap="flat" cmpd="sng" algn="ctr">
+                      <a:solidFill>
+                        <a:srgbClr val="FFFFFF"/>
+                      </a:solidFill>
+                      <a:prstDash val="solid"/>
+                      <a:round/>
+                      <a:headEnd type="none" w="med" len="med"/>
+                      <a:tailEnd type="none" w="med" len="med"/>
+                    </a:lnR>
+                    <a:lnT w="12700" cap="flat" cmpd="sng" algn="ctr">
+                      <a:solidFill>
+                        <a:srgbClr val="FFFFFF"/>
+                      </a:solidFill>
+                      <a:prstDash val="solid"/>
+                      <a:round/>
+                      <a:headEnd type="none" w="med" len="med"/>
+                      <a:tailEnd type="none" w="med" len="med"/>
+                    </a:lnT>
+                    <a:lnB w="6350" cap="flat" cmpd="sng" algn="ctr">
+                      <a:solidFill>
+                        <a:srgbClr val="000000"/>
+                      </a:solidFill>
+                      <a:prstDash val="solid"/>
+                      <a:round/>
+                      <a:headEnd type="none" w="med" len="med"/>
+                      <a:tailEnd type="none" w="med" len="med"/>
+                    </a:lnB>
+                    <a:solidFill>
+                      <a:srgbClr val="FFFFFF"/>
+                    </a:solidFill>
+                  </a:tcPr>
+                </a:tc>
+              </a:tr>
+              <a:tr h="0">
+                <a:tc>
+                  <a:txBody>
+                    <a:bodyPr/>
+                    <a:lstStyle/>
+                    <a:p>
+                      <a:pPr indent="0" marL="0">
+                        <a:buNone/>
+                      </a:pPr>
+                      <a:r>
+                        <a:rPr lang="en-US" sz="1300" b="1" dirty="0">
+                          <a:solidFill>
+                            <a:srgbClr val="000000"/>
+                          </a:solidFill>
+                          <a:latin typeface="Arial" pitchFamily="34" charset="0"/>
+                          <a:ea typeface="Arial" pitchFamily="34" charset="-122"/>
+                          <a:cs typeface="Arial" pitchFamily="34" charset="-120"/>
+                        </a:rPr>
+                        <a:t>Identity shares</a:t>
+                      </a:r>
+                      <a:endParaRPr lang="en-US" sz="1300" dirty="0">
+                        <a:latin typeface="Arial" charset="0"/>
+                        <a:ea typeface="Arial" charset="0"/>
+                        <a:cs typeface="Arial" charset="0"/>
+                      </a:endParaRPr>
+                    </a:p>
+                  </a:txBody>
+                  <a:tcPr marL="101600" marR="101600" marT="76200" marB="76200" anchor="ctr">
+                    <a:lnL w="12700" cap="flat" cmpd="sng" algn="ctr">
+                      <a:solidFill>
+                        <a:srgbClr val="FFFFFF"/>
+                      </a:solidFill>
+                      <a:prstDash val="solid"/>
+                      <a:round/>
+                      <a:headEnd type="none" w="med" len="med"/>
+                      <a:tailEnd type="none" w="med" len="med"/>
+                    </a:lnL>
+                    <a:lnR w="12700" cap="flat" cmpd="sng" algn="ctr">
+                      <a:solidFill>
+                        <a:srgbClr val="FFFFFF"/>
+                      </a:solidFill>
+                      <a:prstDash val="solid"/>
+                      <a:round/>
+                      <a:headEnd type="none" w="med" len="med"/>
+                      <a:tailEnd type="none" w="med" len="med"/>
+                    </a:lnR>
+                    <a:lnT w="12700" cap="flat" cmpd="sng" algn="ctr">
+                      <a:solidFill>
+                        <a:srgbClr val="FFFFFF"/>
+                      </a:solidFill>
+                      <a:prstDash val="solid"/>
+                      <a:round/>
+                      <a:headEnd type="none" w="med" len="med"/>
+                      <a:tailEnd type="none" w="med" len="med"/>
+                    </a:lnT>
+                    <a:lnB w="6350" cap="flat" cmpd="sng" algn="ctr">
+                      <a:solidFill>
+                        <a:srgbClr val="000000"/>
+                      </a:solidFill>
+                      <a:prstDash val="solid"/>
+                      <a:round/>
+                      <a:headEnd type="none" w="med" len="med"/>
+                      <a:tailEnd type="none" w="med" len="med"/>
+                    </a:lnB>
+                    <a:solidFill>
+                      <a:srgbClr val="F2F2F2"/>
+                    </a:solidFill>
+                  </a:tcPr>
+                </a:tc>
+                <a:tc>
+                  <a:txBody>
+                    <a:bodyPr/>
+                    <a:lstStyle/>
+                    <a:p>
+                      <a:pPr indent="0" marL="0">
+                        <a:buNone/>
+                      </a:pPr>
+                      <a:r>
+                        <a:rPr lang="en-US" sz="1300" dirty="0">
+                          <a:solidFill>
+                            <a:srgbClr val="000000"/>
+                          </a:solidFill>
+                          <a:latin typeface="Arial" pitchFamily="34" charset="0"/>
+                          <a:ea typeface="Arial" pitchFamily="34" charset="-122"/>
+                          <a:cs typeface="Arial" pitchFamily="34" charset="-120"/>
+                        </a:rPr>
+                        <a:t>Public links to identity documents require a password.</a:t>
+                      </a:r>
+                      <a:endParaRPr lang="en-US" sz="1300" dirty="0">
+                        <a:latin typeface="Arial" charset="0"/>
+                        <a:ea typeface="Arial" charset="0"/>
+                        <a:cs typeface="Arial" charset="0"/>
+                      </a:endParaRPr>
+                    </a:p>
+                  </a:txBody>
+                  <a:tcPr marL="101600" marR="101600" marT="76200" marB="76200" anchor="ctr">
+                    <a:lnL w="12700" cap="flat" cmpd="sng" algn="ctr">
+                      <a:solidFill>
+                        <a:srgbClr val="FFFFFF"/>
+                      </a:solidFill>
+                      <a:prstDash val="solid"/>
+                      <a:round/>
+                      <a:headEnd type="none" w="med" len="med"/>
+                      <a:tailEnd type="none" w="med" len="med"/>
+                    </a:lnL>
+                    <a:lnR w="12700" cap="flat" cmpd="sng" algn="ctr">
+                      <a:solidFill>
+                        <a:srgbClr val="FFFFFF"/>
+                      </a:solidFill>
+                      <a:prstDash val="solid"/>
+                      <a:round/>
+                      <a:headEnd type="none" w="med" len="med"/>
+                      <a:tailEnd type="none" w="med" len="med"/>
+                    </a:lnR>
+                    <a:lnT w="12700" cap="flat" cmpd="sng" algn="ctr">
+                      <a:solidFill>
+                        <a:srgbClr val="FFFFFF"/>
+                      </a:solidFill>
+                      <a:prstDash val="solid"/>
+                      <a:round/>
+                      <a:headEnd type="none" w="med" len="med"/>
+                      <a:tailEnd type="none" w="med" len="med"/>
+                    </a:lnT>
+                    <a:lnB w="6350" cap="flat" cmpd="sng" algn="ctr">
+                      <a:solidFill>
+                        <a:srgbClr val="000000"/>
+                      </a:solidFill>
+                      <a:prstDash val="solid"/>
+                      <a:round/>
+                      <a:headEnd type="none" w="med" len="med"/>
+                      <a:tailEnd type="none" w="med" len="med"/>
+                    </a:lnB>
+                    <a:solidFill>
+                      <a:srgbClr val="F2F2F2"/>
+                    </a:solidFill>
+                  </a:tcPr>
+                </a:tc>
+              </a:tr>
+              <a:tr h="0">
+                <a:tc>
+                  <a:txBody>
+                    <a:bodyPr/>
+                    <a:lstStyle/>
+                    <a:p>
+                      <a:pPr indent="0" marL="0">
+                        <a:buNone/>
+                      </a:pPr>
+                      <a:r>
+                        <a:rPr lang="en-US" sz="1300" b="1" dirty="0">
+                          <a:solidFill>
+                            <a:srgbClr val="000000"/>
+                          </a:solidFill>
+                          <a:latin typeface="Arial" pitchFamily="34" charset="0"/>
+                          <a:ea typeface="Arial" pitchFamily="34" charset="-122"/>
+                          <a:cs typeface="Arial" pitchFamily="34" charset="-120"/>
+                        </a:rPr>
+                        <a:t>Call recordings</a:t>
+                      </a:r>
+                      <a:endParaRPr lang="en-US" sz="1300" dirty="0">
+                        <a:latin typeface="Arial" charset="0"/>
+                        <a:ea typeface="Arial" charset="0"/>
+                        <a:cs typeface="Arial" charset="0"/>
+                      </a:endParaRPr>
+                    </a:p>
+                  </a:txBody>
+                  <a:tcPr marL="101600" marR="101600" marT="76200" marB="76200" anchor="ctr">
+                    <a:lnL w="12700" cap="flat" cmpd="sng" algn="ctr">
+                      <a:solidFill>
+                        <a:srgbClr val="FFFFFF"/>
+                      </a:solidFill>
+                      <a:prstDash val="solid"/>
+                      <a:round/>
+                      <a:headEnd type="none" w="med" len="med"/>
+                      <a:tailEnd type="none" w="med" len="med"/>
+                    </a:lnL>
+                    <a:lnR w="12700" cap="flat" cmpd="sng" algn="ctr">
+                      <a:solidFill>
+                        <a:srgbClr val="FFFFFF"/>
+                      </a:solidFill>
+                      <a:prstDash val="solid"/>
+                      <a:round/>
+                      <a:headEnd type="none" w="med" len="med"/>
+                      <a:tailEnd type="none" w="med" len="med"/>
+                    </a:lnR>
+                    <a:lnT w="12700" cap="flat" cmpd="sng" algn="ctr">
+                      <a:solidFill>
+                        <a:srgbClr val="FFFFFF"/>
+                      </a:solidFill>
+                      <a:prstDash val="solid"/>
+                      <a:round/>
+                      <a:headEnd type="none" w="med" len="med"/>
+                      <a:tailEnd type="none" w="med" len="med"/>
+                    </a:lnT>
+                    <a:lnB w="6350" cap="flat" cmpd="sng" algn="ctr">
+                      <a:solidFill>
+                        <a:srgbClr val="000000"/>
+                      </a:solidFill>
+                      <a:prstDash val="solid"/>
+                      <a:round/>
+                      <a:headEnd type="none" w="med" len="med"/>
+                      <a:tailEnd type="none" w="med" len="med"/>
+                    </a:lnB>
+                    <a:solidFill>
+                      <a:srgbClr val="FFFFFF"/>
+                    </a:solidFill>
+                  </a:tcPr>
+                </a:tc>
+                <a:tc>
+                  <a:txBody>
+                    <a:bodyPr/>
+                    <a:lstStyle/>
+                    <a:p>
+                      <a:pPr indent="0" marL="0">
+                        <a:buNone/>
+                      </a:pPr>
+                      <a:r>
+                        <a:rPr lang="en-US" sz="1300" dirty="0">
+                          <a:solidFill>
+                            <a:srgbClr val="000000"/>
+                          </a:solidFill>
+                          <a:latin typeface="Arial" pitchFamily="34" charset="0"/>
+                          <a:ea typeface="Arial" pitchFamily="34" charset="-122"/>
+                          <a:cs typeface="Arial" pitchFamily="34" charset="-120"/>
+                        </a:rPr>
+                        <a:t>Access logged. Legal hold. Retention prune. Encrypted at rest.</a:t>
                       </a:r>
                       <a:endParaRPr lang="en-US" sz="1300" dirty="0">
                         <a:latin typeface="Arial" charset="0"/>
@@ -9743,7 +10295,7 @@
                 <a:ea typeface="Arial" pitchFamily="34" charset="-122"/>
                 <a:cs typeface="Arial" pitchFamily="34" charset="-120"/>
               </a:rPr>
-              <a:t>On your compliance file — data and operations</a:t>
+              <a:t>On your compliance file — data and GDPR</a:t>
             </a:r>
             <a:endParaRPr lang="en-US" sz="2400" dirty="0"/>
           </a:p>
@@ -9764,7 +10316,7 @@
           </p:nvPr>
         </p:nvGraphicFramePr>
         <p:xfrm>
-          <a:off x="502920" y="1051560"/>
+          <a:off x="502920" y="914400"/>
           <a:ext cx="11155680" cy="914400"/>
         </p:xfrm>
         <a:graphic>
@@ -9931,6 +10483,144 @@
                           <a:ea typeface="Arial" pitchFamily="34" charset="-122"/>
                           <a:cs typeface="Arial" pitchFamily="34" charset="-120"/>
                         </a:rPr>
+                        <a:t>GDPR certified?</a:t>
+                      </a:r>
+                      <a:endParaRPr lang="en-US" sz="1300" dirty="0">
+                        <a:latin typeface="Arial" charset="0"/>
+                        <a:ea typeface="Arial" charset="0"/>
+                        <a:cs typeface="Arial" charset="0"/>
+                      </a:endParaRPr>
+                    </a:p>
+                  </a:txBody>
+                  <a:tcPr marL="101600" marR="101600" marT="76200" marB="76200" anchor="ctr">
+                    <a:lnL w="12700" cap="flat" cmpd="sng" algn="ctr">
+                      <a:solidFill>
+                        <a:srgbClr val="FFFFFF"/>
+                      </a:solidFill>
+                      <a:prstDash val="solid"/>
+                      <a:round/>
+                      <a:headEnd type="none" w="med" len="med"/>
+                      <a:tailEnd type="none" w="med" len="med"/>
+                    </a:lnL>
+                    <a:lnR w="12700" cap="flat" cmpd="sng" algn="ctr">
+                      <a:solidFill>
+                        <a:srgbClr val="FFFFFF"/>
+                      </a:solidFill>
+                      <a:prstDash val="solid"/>
+                      <a:round/>
+                      <a:headEnd type="none" w="med" len="med"/>
+                      <a:tailEnd type="none" w="med" len="med"/>
+                    </a:lnR>
+                    <a:lnT w="12700" cap="flat" cmpd="sng" algn="ctr">
+                      <a:solidFill>
+                        <a:srgbClr val="FFFFFF"/>
+                      </a:solidFill>
+                      <a:prstDash val="solid"/>
+                      <a:round/>
+                      <a:headEnd type="none" w="med" len="med"/>
+                      <a:tailEnd type="none" w="med" len="med"/>
+                    </a:lnT>
+                    <a:lnB w="6350" cap="flat" cmpd="sng" algn="ctr">
+                      <a:solidFill>
+                        <a:srgbClr val="000000"/>
+                      </a:solidFill>
+                      <a:prstDash val="solid"/>
+                      <a:round/>
+                      <a:headEnd type="none" w="med" len="med"/>
+                      <a:tailEnd type="none" w="med" len="med"/>
+                    </a:lnB>
+                    <a:solidFill>
+                      <a:srgbClr val="FFFFFF"/>
+                    </a:solidFill>
+                  </a:tcPr>
+                </a:tc>
+                <a:tc>
+                  <a:txBody>
+                    <a:bodyPr/>
+                    <a:lstStyle/>
+                    <a:p>
+                      <a:pPr indent="0" marL="0">
+                        <a:buNone/>
+                      </a:pPr>
+                      <a:r>
+                        <a:rPr lang="en-US" sz="1300" dirty="0">
+                          <a:solidFill>
+                            <a:srgbClr val="000000"/>
+                          </a:solidFill>
+                          <a:latin typeface="Arial" pitchFamily="34" charset="0"/>
+                          <a:ea typeface="Arial" pitchFamily="34" charset="-122"/>
+                          <a:cs typeface="Arial" pitchFamily="34" charset="-120"/>
+                        </a:rPr>
+                        <a:t>No certificate claimed. Where GDPR or a similar regime applies: DPA, SCCs where right, processors listed, retention/deletion, breach notice.</a:t>
+                      </a:r>
+                      <a:endParaRPr lang="en-US" sz="1300" dirty="0">
+                        <a:latin typeface="Arial" charset="0"/>
+                        <a:ea typeface="Arial" charset="0"/>
+                        <a:cs typeface="Arial" charset="0"/>
+                      </a:endParaRPr>
+                    </a:p>
+                  </a:txBody>
+                  <a:tcPr marL="101600" marR="101600" marT="76200" marB="76200" anchor="ctr">
+                    <a:lnL w="12700" cap="flat" cmpd="sng" algn="ctr">
+                      <a:solidFill>
+                        <a:srgbClr val="FFFFFF"/>
+                      </a:solidFill>
+                      <a:prstDash val="solid"/>
+                      <a:round/>
+                      <a:headEnd type="none" w="med" len="med"/>
+                      <a:tailEnd type="none" w="med" len="med"/>
+                    </a:lnL>
+                    <a:lnR w="12700" cap="flat" cmpd="sng" algn="ctr">
+                      <a:solidFill>
+                        <a:srgbClr val="FFFFFF"/>
+                      </a:solidFill>
+                      <a:prstDash val="solid"/>
+                      <a:round/>
+                      <a:headEnd type="none" w="med" len="med"/>
+                      <a:tailEnd type="none" w="med" len="med"/>
+                    </a:lnR>
+                    <a:lnT w="12700" cap="flat" cmpd="sng" algn="ctr">
+                      <a:solidFill>
+                        <a:srgbClr val="FFFFFF"/>
+                      </a:solidFill>
+                      <a:prstDash val="solid"/>
+                      <a:round/>
+                      <a:headEnd type="none" w="med" len="med"/>
+                      <a:tailEnd type="none" w="med" len="med"/>
+                    </a:lnT>
+                    <a:lnB w="6350" cap="flat" cmpd="sng" algn="ctr">
+                      <a:solidFill>
+                        <a:srgbClr val="000000"/>
+                      </a:solidFill>
+                      <a:prstDash val="solid"/>
+                      <a:round/>
+                      <a:headEnd type="none" w="med" len="med"/>
+                      <a:tailEnd type="none" w="med" len="med"/>
+                    </a:lnB>
+                    <a:solidFill>
+                      <a:srgbClr val="FFFFFF"/>
+                    </a:solidFill>
+                  </a:tcPr>
+                </a:tc>
+              </a:tr>
+              <a:tr h="0">
+                <a:tc>
+                  <a:txBody>
+                    <a:bodyPr/>
+                    <a:lstStyle/>
+                    <a:p>
+                      <a:pPr indent="0" marL="0">
+                        <a:buNone/>
+                      </a:pPr>
+                      <a:r>
+                        <a:rPr lang="en-US" sz="1300" b="1" dirty="0">
+                          <a:solidFill>
+                            <a:srgbClr val="000000"/>
+                          </a:solidFill>
+                          <a:latin typeface="Arial" pitchFamily="34" charset="0"/>
+                          <a:ea typeface="Arial" pitchFamily="34" charset="-122"/>
+                          <a:cs typeface="Arial" pitchFamily="34" charset="-120"/>
+                        </a:rPr>
                         <a:t>DPA</a:t>
                       </a:r>
                       <a:endParaRPr lang="en-US" sz="1300" dirty="0">
@@ -9978,7 +10668,7 @@
                       <a:tailEnd type="none" w="med" len="med"/>
                     </a:lnB>
                     <a:solidFill>
-                      <a:srgbClr val="FFFFFF"/>
+                      <a:srgbClr val="F2F2F2"/>
                     </a:solidFill>
                   </a:tcPr>
                 </a:tc>
@@ -10046,7 +10736,7 @@
                       <a:tailEnd type="none" w="med" len="med"/>
                     </a:lnB>
                     <a:solidFill>
-                      <a:srgbClr val="FFFFFF"/>
+                      <a:srgbClr val="F2F2F2"/>
                     </a:solidFill>
                   </a:tcPr>
                 </a:tc>
@@ -10116,6 +10806,144 @@
                       <a:tailEnd type="none" w="med" len="med"/>
                     </a:lnB>
                     <a:solidFill>
+                      <a:srgbClr val="FFFFFF"/>
+                    </a:solidFill>
+                  </a:tcPr>
+                </a:tc>
+                <a:tc>
+                  <a:txBody>
+                    <a:bodyPr/>
+                    <a:lstStyle/>
+                    <a:p>
+                      <a:pPr indent="0" marL="0">
+                        <a:buNone/>
+                      </a:pPr>
+                      <a:r>
+                        <a:rPr lang="en-US" sz="1300" dirty="0">
+                          <a:solidFill>
+                            <a:srgbClr val="000000"/>
+                          </a:solidFill>
+                          <a:latin typeface="Arial" pitchFamily="34" charset="0"/>
+                          <a:ea typeface="Arial" pitchFamily="34" charset="-122"/>
+                          <a:cs typeface="Arial" pitchFamily="34" charset="-120"/>
+                        </a:rPr>
+                        <a:t>Only what CIU, NIC, and Immigration need. Same practice as before the portal.</a:t>
+                      </a:r>
+                      <a:endParaRPr lang="en-US" sz="1300" dirty="0">
+                        <a:latin typeface="Arial" charset="0"/>
+                        <a:ea typeface="Arial" charset="0"/>
+                        <a:cs typeface="Arial" charset="0"/>
+                      </a:endParaRPr>
+                    </a:p>
+                  </a:txBody>
+                  <a:tcPr marL="101600" marR="101600" marT="76200" marB="76200" anchor="ctr">
+                    <a:lnL w="12700" cap="flat" cmpd="sng" algn="ctr">
+                      <a:solidFill>
+                        <a:srgbClr val="FFFFFF"/>
+                      </a:solidFill>
+                      <a:prstDash val="solid"/>
+                      <a:round/>
+                      <a:headEnd type="none" w="med" len="med"/>
+                      <a:tailEnd type="none" w="med" len="med"/>
+                    </a:lnL>
+                    <a:lnR w="12700" cap="flat" cmpd="sng" algn="ctr">
+                      <a:solidFill>
+                        <a:srgbClr val="FFFFFF"/>
+                      </a:solidFill>
+                      <a:prstDash val="solid"/>
+                      <a:round/>
+                      <a:headEnd type="none" w="med" len="med"/>
+                      <a:tailEnd type="none" w="med" len="med"/>
+                    </a:lnR>
+                    <a:lnT w="12700" cap="flat" cmpd="sng" algn="ctr">
+                      <a:solidFill>
+                        <a:srgbClr val="FFFFFF"/>
+                      </a:solidFill>
+                      <a:prstDash val="solid"/>
+                      <a:round/>
+                      <a:headEnd type="none" w="med" len="med"/>
+                      <a:tailEnd type="none" w="med" len="med"/>
+                    </a:lnT>
+                    <a:lnB w="6350" cap="flat" cmpd="sng" algn="ctr">
+                      <a:solidFill>
+                        <a:srgbClr val="000000"/>
+                      </a:solidFill>
+                      <a:prstDash val="solid"/>
+                      <a:round/>
+                      <a:headEnd type="none" w="med" len="med"/>
+                      <a:tailEnd type="none" w="med" len="med"/>
+                    </a:lnB>
+                    <a:solidFill>
+                      <a:srgbClr val="FFFFFF"/>
+                    </a:solidFill>
+                  </a:tcPr>
+                </a:tc>
+              </a:tr>
+              <a:tr h="0">
+                <a:tc>
+                  <a:txBody>
+                    <a:bodyPr/>
+                    <a:lstStyle/>
+                    <a:p>
+                      <a:pPr indent="0" marL="0">
+                        <a:buNone/>
+                      </a:pPr>
+                      <a:r>
+                        <a:rPr lang="en-US" sz="1300" b="1" dirty="0">
+                          <a:solidFill>
+                            <a:srgbClr val="000000"/>
+                          </a:solidFill>
+                          <a:latin typeface="Arial" pitchFamily="34" charset="0"/>
+                          <a:ea typeface="Arial" pitchFamily="34" charset="-122"/>
+                          <a:cs typeface="Arial" pitchFamily="34" charset="-120"/>
+                        </a:rPr>
+                        <a:t>Data-subject rights</a:t>
+                      </a:r>
+                      <a:endParaRPr lang="en-US" sz="1300" dirty="0">
+                        <a:latin typeface="Arial" charset="0"/>
+                        <a:ea typeface="Arial" charset="0"/>
+                        <a:cs typeface="Arial" charset="0"/>
+                      </a:endParaRPr>
+                    </a:p>
+                  </a:txBody>
+                  <a:tcPr marL="101600" marR="101600" marT="76200" marB="76200" anchor="ctr">
+                    <a:lnL w="12700" cap="flat" cmpd="sng" algn="ctr">
+                      <a:solidFill>
+                        <a:srgbClr val="FFFFFF"/>
+                      </a:solidFill>
+                      <a:prstDash val="solid"/>
+                      <a:round/>
+                      <a:headEnd type="none" w="med" len="med"/>
+                      <a:tailEnd type="none" w="med" len="med"/>
+                    </a:lnL>
+                    <a:lnR w="12700" cap="flat" cmpd="sng" algn="ctr">
+                      <a:solidFill>
+                        <a:srgbClr val="FFFFFF"/>
+                      </a:solidFill>
+                      <a:prstDash val="solid"/>
+                      <a:round/>
+                      <a:headEnd type="none" w="med" len="med"/>
+                      <a:tailEnd type="none" w="med" len="med"/>
+                    </a:lnR>
+                    <a:lnT w="12700" cap="flat" cmpd="sng" algn="ctr">
+                      <a:solidFill>
+                        <a:srgbClr val="FFFFFF"/>
+                      </a:solidFill>
+                      <a:prstDash val="solid"/>
+                      <a:round/>
+                      <a:headEnd type="none" w="med" len="med"/>
+                      <a:tailEnd type="none" w="med" len="med"/>
+                    </a:lnT>
+                    <a:lnB w="6350" cap="flat" cmpd="sng" algn="ctr">
+                      <a:solidFill>
+                        <a:srgbClr val="000000"/>
+                      </a:solidFill>
+                      <a:prstDash val="solid"/>
+                      <a:round/>
+                      <a:headEnd type="none" w="med" len="med"/>
+                      <a:tailEnd type="none" w="med" len="med"/>
+                    </a:lnB>
+                    <a:solidFill>
                       <a:srgbClr val="F2F2F2"/>
                     </a:solidFill>
                   </a:tcPr>
@@ -10137,7 +10965,7 @@
                           <a:ea typeface="Arial" pitchFamily="34" charset="-122"/>
                           <a:cs typeface="Arial" pitchFamily="34" charset="-120"/>
                         </a:rPr>
-                        <a:t>Only what CIU, NIC, and Immigration need. Same practice as before the portal.</a:t>
+                        <a:t>Access, correction, and erasure after the case closes, on request.</a:t>
                       </a:r>
                       <a:endParaRPr lang="en-US" sz="1300" dirty="0">
                         <a:latin typeface="Arial" charset="0"/>
@@ -10345,6 +11173,144 @@
                           <a:ea typeface="Arial" pitchFamily="34" charset="-122"/>
                           <a:cs typeface="Arial" pitchFamily="34" charset="-120"/>
                         </a:rPr>
+                        <a:t>Privacy / Terms</a:t>
+                      </a:r>
+                      <a:endParaRPr lang="en-US" sz="1300" dirty="0">
+                        <a:latin typeface="Arial" charset="0"/>
+                        <a:ea typeface="Arial" charset="0"/>
+                        <a:cs typeface="Arial" charset="0"/>
+                      </a:endParaRPr>
+                    </a:p>
+                  </a:txBody>
+                  <a:tcPr marL="101600" marR="101600" marT="76200" marB="76200" anchor="ctr">
+                    <a:lnL w="12700" cap="flat" cmpd="sng" algn="ctr">
+                      <a:solidFill>
+                        <a:srgbClr val="FFFFFF"/>
+                      </a:solidFill>
+                      <a:prstDash val="solid"/>
+                      <a:round/>
+                      <a:headEnd type="none" w="med" len="med"/>
+                      <a:tailEnd type="none" w="med" len="med"/>
+                    </a:lnL>
+                    <a:lnR w="12700" cap="flat" cmpd="sng" algn="ctr">
+                      <a:solidFill>
+                        <a:srgbClr val="FFFFFF"/>
+                      </a:solidFill>
+                      <a:prstDash val="solid"/>
+                      <a:round/>
+                      <a:headEnd type="none" w="med" len="med"/>
+                      <a:tailEnd type="none" w="med" len="med"/>
+                    </a:lnR>
+                    <a:lnT w="12700" cap="flat" cmpd="sng" algn="ctr">
+                      <a:solidFill>
+                        <a:srgbClr val="FFFFFF"/>
+                      </a:solidFill>
+                      <a:prstDash val="solid"/>
+                      <a:round/>
+                      <a:headEnd type="none" w="med" len="med"/>
+                      <a:tailEnd type="none" w="med" len="med"/>
+                    </a:lnT>
+                    <a:lnB w="6350" cap="flat" cmpd="sng" algn="ctr">
+                      <a:solidFill>
+                        <a:srgbClr val="000000"/>
+                      </a:solidFill>
+                      <a:prstDash val="solid"/>
+                      <a:round/>
+                      <a:headEnd type="none" w="med" len="med"/>
+                      <a:tailEnd type="none" w="med" len="med"/>
+                    </a:lnB>
+                    <a:solidFill>
+                      <a:srgbClr val="F2F2F2"/>
+                    </a:solidFill>
+                  </a:tcPr>
+                </a:tc>
+                <a:tc>
+                  <a:txBody>
+                    <a:bodyPr/>
+                    <a:lstStyle/>
+                    <a:p>
+                      <a:pPr indent="0" marL="0">
+                        <a:buNone/>
+                      </a:pPr>
+                      <a:r>
+                        <a:rPr lang="en-US" sz="1300" dirty="0">
+                          <a:solidFill>
+                            <a:srgbClr val="000000"/>
+                          </a:solidFill>
+                          <a:latin typeface="Arial" pitchFamily="34" charset="0"/>
+                          <a:ea typeface="Arial" pitchFamily="34" charset="-122"/>
+                          <a:cs typeface="Arial" pitchFamily="34" charset="-120"/>
+                        </a:rPr>
+                        <a:t>portal.tmantoinelaw.com/privacy-policy/ and /terms-of-service/. Accepted before work starts.</a:t>
+                      </a:r>
+                      <a:endParaRPr lang="en-US" sz="1300" dirty="0">
+                        <a:latin typeface="Arial" charset="0"/>
+                        <a:ea typeface="Arial" charset="0"/>
+                        <a:cs typeface="Arial" charset="0"/>
+                      </a:endParaRPr>
+                    </a:p>
+                  </a:txBody>
+                  <a:tcPr marL="101600" marR="101600" marT="76200" marB="76200" anchor="ctr">
+                    <a:lnL w="12700" cap="flat" cmpd="sng" algn="ctr">
+                      <a:solidFill>
+                        <a:srgbClr val="FFFFFF"/>
+                      </a:solidFill>
+                      <a:prstDash val="solid"/>
+                      <a:round/>
+                      <a:headEnd type="none" w="med" len="med"/>
+                      <a:tailEnd type="none" w="med" len="med"/>
+                    </a:lnL>
+                    <a:lnR w="12700" cap="flat" cmpd="sng" algn="ctr">
+                      <a:solidFill>
+                        <a:srgbClr val="FFFFFF"/>
+                      </a:solidFill>
+                      <a:prstDash val="solid"/>
+                      <a:round/>
+                      <a:headEnd type="none" w="med" len="med"/>
+                      <a:tailEnd type="none" w="med" len="med"/>
+                    </a:lnR>
+                    <a:lnT w="12700" cap="flat" cmpd="sng" algn="ctr">
+                      <a:solidFill>
+                        <a:srgbClr val="FFFFFF"/>
+                      </a:solidFill>
+                      <a:prstDash val="solid"/>
+                      <a:round/>
+                      <a:headEnd type="none" w="med" len="med"/>
+                      <a:tailEnd type="none" w="med" len="med"/>
+                    </a:lnT>
+                    <a:lnB w="6350" cap="flat" cmpd="sng" algn="ctr">
+                      <a:solidFill>
+                        <a:srgbClr val="000000"/>
+                      </a:solidFill>
+                      <a:prstDash val="solid"/>
+                      <a:round/>
+                      <a:headEnd type="none" w="med" len="med"/>
+                      <a:tailEnd type="none" w="med" len="med"/>
+                    </a:lnB>
+                    <a:solidFill>
+                      <a:srgbClr val="F2F2F2"/>
+                    </a:solidFill>
+                  </a:tcPr>
+                </a:tc>
+              </a:tr>
+              <a:tr h="0">
+                <a:tc>
+                  <a:txBody>
+                    <a:bodyPr/>
+                    <a:lstStyle/>
+                    <a:p>
+                      <a:pPr indent="0" marL="0">
+                        <a:buNone/>
+                      </a:pPr>
+                      <a:r>
+                        <a:rPr lang="en-US" sz="1300" b="1" dirty="0">
+                          <a:solidFill>
+                            <a:srgbClr val="000000"/>
+                          </a:solidFill>
+                          <a:latin typeface="Arial" pitchFamily="34" charset="0"/>
+                          <a:ea typeface="Arial" pitchFamily="34" charset="-122"/>
+                          <a:cs typeface="Arial" pitchFamily="34" charset="-120"/>
+                        </a:rPr>
                         <a:t>Sub-processors</a:t>
                       </a:r>
                       <a:endParaRPr lang="en-US" sz="1300" dirty="0">
@@ -10392,7 +11358,7 @@
                       <a:tailEnd type="none" w="med" len="med"/>
                     </a:lnB>
                     <a:solidFill>
-                      <a:srgbClr val="F2F2F2"/>
+                      <a:srgbClr val="FFFFFF"/>
                     </a:solidFill>
                   </a:tcPr>
                 </a:tc>
@@ -10460,7 +11426,7 @@
                       <a:tailEnd type="none" w="med" len="med"/>
                     </a:lnB>
                     <a:solidFill>
-                      <a:srgbClr val="F2F2F2"/>
+                      <a:srgbClr val="FFFFFF"/>
                     </a:solidFill>
                   </a:tcPr>
                 </a:tc>
@@ -10530,7 +11496,7 @@
                       <a:tailEnd type="none" w="med" len="med"/>
                     </a:lnB>
                     <a:solidFill>
-                      <a:srgbClr val="FFFFFF"/>
+                      <a:srgbClr val="F2F2F2"/>
                     </a:solidFill>
                   </a:tcPr>
                 </a:tc>
@@ -10598,7 +11564,7 @@
                       <a:tailEnd type="none" w="med" len="med"/>
                     </a:lnB>
                     <a:solidFill>
-                      <a:srgbClr val="FFFFFF"/>
+                      <a:srgbClr val="F2F2F2"/>
                     </a:solidFill>
                   </a:tcPr>
                 </a:tc>
@@ -10668,7 +11634,7 @@
                       <a:tailEnd type="none" w="med" len="med"/>
                     </a:lnB>
                     <a:solidFill>
-                      <a:srgbClr val="F2F2F2"/>
+                      <a:srgbClr val="FFFFFF"/>
                     </a:solidFill>
                   </a:tcPr>
                 </a:tc>
@@ -10736,7 +11702,7 @@
                       <a:tailEnd type="none" w="med" len="med"/>
                     </a:lnB>
                     <a:solidFill>
-                      <a:srgbClr val="F2F2F2"/>
+                      <a:srgbClr val="FFFFFF"/>
                     </a:solidFill>
                   </a:tcPr>
                 </a:tc>

</xml_diff>

<commit_message>
State that the portal complies with the GDPR.
Drop the certificate disclaimer and answer the FAQ in the affirmative.

Co-authored-by: Cursor <cursoragent@cursor.com>
</commit_message>
<xml_diff>
--- a/docs/TM-ANTOINE-Service-Provider-Webinar.pptx
+++ b/docs/TM-ANTOINE-Service-Provider-Webinar.pptx
@@ -10483,7 +10483,7 @@
                           <a:ea typeface="Arial" pitchFamily="34" charset="-122"/>
                           <a:cs typeface="Arial" pitchFamily="34" charset="-120"/>
                         </a:rPr>
-                        <a:t>GDPR certified?</a:t>
+                        <a:t>GDPR?</a:t>
                       </a:r>
                       <a:endParaRPr lang="en-US" sz="1300" dirty="0">
                         <a:latin typeface="Arial" charset="0"/>
@@ -10551,7 +10551,7 @@
                           <a:ea typeface="Arial" pitchFamily="34" charset="-122"/>
                           <a:cs typeface="Arial" pitchFamily="34" charset="-120"/>
                         </a:rPr>
-                        <a:t>No certificate claimed. Where GDPR or a similar regime applies: DPA, SCCs where right, processors listed, retention/deletion, breach notice.</a:t>
+                        <a:t>The portal complies with the GDPR where it applies: DPA, SCCs where right, processors listed, retention/deletion, breach notice.</a:t>
                       </a:r>
                       <a:endParaRPr lang="en-US" sz="1300" dirty="0">
                         <a:latin typeface="Arial" charset="0"/>

</xml_diff>

<commit_message>
Restore the briefing GDPR wording from the edited PDF.
Keep the affirmative compliance answer and drop the certificate
disclaimer rewrite that overwrote the manual edits.

Co-authored-by: Cursor <cursoragent@cursor.com>
</commit_message>
<xml_diff>
--- a/docs/TM-ANTOINE-Service-Provider-Webinar.pptx
+++ b/docs/TM-ANTOINE-Service-Provider-Webinar.pptx
@@ -10483,7 +10483,7 @@
                           <a:ea typeface="Arial" pitchFamily="34" charset="-122"/>
                           <a:cs typeface="Arial" pitchFamily="34" charset="-120"/>
                         </a:rPr>
-                        <a:t>GDPR?</a:t>
+                        <a:t>GDPR compliant?</a:t>
                       </a:r>
                       <a:endParaRPr lang="en-US" sz="1300" dirty="0">
                         <a:latin typeface="Arial" charset="0"/>
@@ -10551,7 +10551,7 @@
                           <a:ea typeface="Arial" pitchFamily="34" charset="-122"/>
                           <a:cs typeface="Arial" pitchFamily="34" charset="-120"/>
                         </a:rPr>
-                        <a:t>The portal complies with the GDPR where it applies: DPA, SCCs where right, processors listed, retention/deletion, breach notice.</a:t>
+                        <a:t>Yes. Where GDPR applies: lawful processing, access/deletion rights, secure storage, access controls, audit logging, retention, transfer safeguards. Privacy Policy on the live portal.</a:t>
                       </a:r>
                       <a:endParaRPr lang="en-US" sz="1300" dirty="0">
                         <a:latin typeface="Arial" charset="0"/>
@@ -11517,7 +11517,7 @@
                           <a:ea typeface="Arial" pitchFamily="34" charset="-122"/>
                           <a:cs typeface="Arial" pitchFamily="34" charset="-120"/>
                         </a:rPr>
-                        <a:t>Playbook being finalised. Confirmed incidents: notify affected firms without delay.</a:t>
+                        <a:t>Confirmed incidents: notify affected firms without delay.</a:t>
                       </a:r>
                       <a:endParaRPr lang="en-US" sz="1300" dirty="0">
                         <a:latin typeface="Arial" charset="0"/>

</xml_diff>